<commit_message>
Update VOIS Major Project presentation template with complete project data, results, charts, and certificate
</commit_message>
<xml_diff>
--- a/VOIS_Major_Project_PPT_Submission_Template.pptx
+++ b/VOIS_Major_Project_PPT_Submission_Template.pptx
@@ -10047,19 +10047,21 @@
           </a:xfrm>
         </p:spPr>
         <p:txBody>
-          <a:bodyPr vert="horz" lIns="91440" tIns="45720" rIns="91440" bIns="45720" rtlCol="0" anchor="t">
+          <a:bodyPr vert="horz" lIns="91440" tIns="45720" rIns="91440" bIns="45720" rtlCol="0" anchor="t" wrap="square">
             <a:normAutofit/>
           </a:bodyPr>
           <a:lstStyle/>
           <a:p>
-            <a:pPr algn="r"/>
+            <a:pPr algn="r">
+              <a:defRPr sz="1400" b="1">
+                <a:solidFill>
+                  <a:srgbClr val="1E1E1E"/>
+                </a:solidFill>
+                <a:latin typeface="Arial"/>
+              </a:defRPr>
+            </a:pPr>
             <a:r>
-              <a:rPr lang="en-US" b="0" dirty="0">
-                <a:solidFill>
-                  <a:schemeClr val="tx1"/>
-                </a:solidFill>
-              </a:rPr>
-              <a:t>[Student Name </a:t>
+              <a:t>[Student Name- ARYAN</a:t>
             </a:r>
             <a:endParaRPr lang="en-IN" b="0" dirty="0">
               <a:solidFill>
@@ -10068,20 +10070,17 @@
             </a:endParaRPr>
           </a:p>
           <a:p>
-            <a:pPr algn="r"/>
+            <a:pPr>
+              <a:defRPr sz="1400" b="1">
+                <a:solidFill>
+                  <a:srgbClr val="1E1E1E"/>
+                </a:solidFill>
+                <a:latin typeface="Arial"/>
+              </a:defRPr>
+            </a:pPr>
             <a:r>
-              <a:rPr lang="en-US" b="0" dirty="0">
-                <a:solidFill>
-                  <a:schemeClr val="tx1"/>
-                </a:solidFill>
-              </a:rPr>
-              <a:t>College Name- ]</a:t>
+              <a:t>College Name- Panipat Institute Of Engineering &amp; Technology ]</a:t>
             </a:r>
-            <a:endParaRPr lang="en-IN" b="0" dirty="0">
-              <a:solidFill>
-                <a:schemeClr val="tx1"/>
-              </a:solidFill>
-            </a:endParaRPr>
           </a:p>
         </p:txBody>
       </p:sp>
@@ -10108,14 +10107,21 @@
           </a:xfrm>
         </p:spPr>
         <p:txBody>
-          <a:bodyPr>
+          <a:bodyPr wrap="square">
             <a:normAutofit/>
           </a:bodyPr>
           <a:lstStyle/>
           <a:p>
+            <a:pPr>
+              <a:defRPr sz="2400" b="1">
+                <a:solidFill>
+                  <a:srgbClr val="003366"/>
+                </a:solidFill>
+                <a:latin typeface="Arial"/>
+              </a:defRPr>
+            </a:pPr>
             <a:r>
-              <a:rPr lang="en-GB" sz="3200" dirty="0"/>
-              <a:t>Project Title -</a:t>
+              <a:t>Project Title -Seasonal Agriculture Performance Analysis</a:t>
             </a:r>
             <a:endParaRPr lang="en-IN" sz="3200" dirty="0"/>
           </a:p>
@@ -10434,9 +10440,16 @@
           </a:bodyPr>
           <a:lstStyle/>
           <a:p>
+            <a:pPr>
+              <a:defRPr sz="1300" b="1">
+                <a:solidFill>
+                  <a:srgbClr val="1E1E1E"/>
+                </a:solidFill>
+                <a:latin typeface="Arial"/>
+              </a:defRPr>
+            </a:pPr>
             <a:r>
-              <a:rPr lang="en-US" b="1" dirty="0"/>
-              <a:t>AICTE STU ID : (its available in your offer letter)</a:t>
+              <a:t>AICTE STU ID : STU6a191e1abc17a1780031002</a:t>
             </a:r>
           </a:p>
         </p:txBody>
@@ -11086,14 +11099,21 @@
           </a:xfrm>
         </p:spPr>
         <p:txBody>
-          <a:bodyPr>
+          <a:bodyPr wrap="square">
             <a:normAutofit/>
           </a:bodyPr>
           <a:lstStyle/>
           <a:p>
+            <a:pPr>
+              <a:defRPr sz="2400" b="1">
+                <a:solidFill>
+                  <a:srgbClr val="003366"/>
+                </a:solidFill>
+                <a:latin typeface="Arial"/>
+              </a:defRPr>
+            </a:pPr>
             <a:r>
-              <a:rPr lang="en-GB" dirty="0"/>
-              <a:t>RESULTS </a:t>
+              <a:t>RESULTS</a:t>
             </a:r>
             <a:endParaRPr lang="en-IN" dirty="0"/>
           </a:p>
@@ -11634,16 +11654,12 @@
           </a:xfrm>
         </p:spPr>
         <p:txBody>
-          <a:bodyPr/>
+          <a:bodyPr wrap="square"/>
           <a:lstStyle/>
           <a:p>
             <a:pPr marL="0" indent="0">
               <a:buNone/>
             </a:pPr>
-            <a:r>
-              <a:rPr lang="en-US" dirty="0"/>
-              <a:t>[Add screen shots of your code ]</a:t>
-            </a:r>
             <a:endParaRPr lang="en-IN" dirty="0"/>
           </a:p>
         </p:txBody>
@@ -12194,13 +12210,20 @@
           </a:xfrm>
         </p:spPr>
         <p:txBody>
-          <a:bodyPr>
+          <a:bodyPr wrap="square">
             <a:normAutofit/>
           </a:bodyPr>
           <a:lstStyle/>
           <a:p>
+            <a:pPr>
+              <a:defRPr sz="2200" b="1">
+                <a:solidFill>
+                  <a:srgbClr val="003366"/>
+                </a:solidFill>
+                <a:latin typeface="Arial"/>
+              </a:defRPr>
+            </a:pPr>
             <a:r>
-              <a:rPr lang="en-IN" sz="4000" dirty="0"/>
               <a:t>Future scope</a:t>
             </a:r>
           </a:p>
@@ -12230,7 +12253,7 @@
           </a:prstGeom>
         </p:spPr>
         <p:txBody>
-          <a:bodyPr vert="horz" lIns="91440" tIns="45720" rIns="91440" bIns="45720" rtlCol="0">
+          <a:bodyPr vert="horz" lIns="91440" tIns="45720" rIns="91440" bIns="45720" rtlCol="0" wrap="square">
             <a:normAutofit/>
           </a:bodyPr>
           <a:lstStyle>
@@ -12458,7 +12481,214 @@
             </a:lvl9pPr>
           </a:lstStyle>
           <a:p>
+            <a:pPr>
+              <a:defRPr sz="900" b="0">
+                <a:solidFill>
+                  <a:srgbClr val="1E1E1E"/>
+                </a:solidFill>
+                <a:latin typeface="Arial"/>
+              </a:defRPr>
+            </a:pPr>
+            <a:r>
+              <a:t>While the current project focuses strictly on Data Analytics, Statistical Exploration, and Visual Insights, it provides a solid foundation for several advanced future enhancements:</a:t>
+            </a:r>
             <a:endParaRPr lang="en-GB" sz="2000" dirty="0"/>
+          </a:p>
+          <a:p>
+            <a:pPr>
+              <a:defRPr sz="900" b="0">
+                <a:solidFill>
+                  <a:srgbClr val="1E1E1E"/>
+                </a:solidFill>
+                <a:latin typeface="Arial"/>
+              </a:defRPr>
+            </a:pPr>
+          </a:p>
+          <a:p>
+            <a:pPr>
+              <a:defRPr sz="900" b="0">
+                <a:solidFill>
+                  <a:srgbClr val="1E1E1E"/>
+                </a:solidFill>
+                <a:latin typeface="Arial"/>
+              </a:defRPr>
+            </a:pPr>
+            <a:r>
+              <a:t>1. Predictive Machine Learning (ML) Models</a:t>
+            </a:r>
+          </a:p>
+          <a:p>
+            <a:pPr>
+              <a:defRPr sz="900" b="0">
+                <a:solidFill>
+                  <a:srgbClr val="1E1E1E"/>
+                </a:solidFill>
+                <a:latin typeface="Arial"/>
+              </a:defRPr>
+            </a:pPr>
+            <a:r>
+              <a:t>   - Crop Yield Prediction: Implement regression models (Random Forest, XGBoost) to predict yield (Tonnes/Ha).</a:t>
+            </a:r>
+          </a:p>
+          <a:p>
+            <a:pPr>
+              <a:defRPr sz="900" b="0">
+                <a:solidFill>
+                  <a:srgbClr val="1E1E1E"/>
+                </a:solidFill>
+                <a:latin typeface="Arial"/>
+              </a:defRPr>
+            </a:pPr>
+            <a:r>
+              <a:t>   - Pest &amp; Disease Risk Forecasting: Build classification models to forecast high pest risk probability (&gt;50%).</a:t>
+            </a:r>
+          </a:p>
+          <a:p>
+            <a:pPr>
+              <a:defRPr sz="900" b="0">
+                <a:solidFill>
+                  <a:srgbClr val="1E1E1E"/>
+                </a:solidFill>
+                <a:latin typeface="Arial"/>
+              </a:defRPr>
+            </a:pPr>
+            <a:r>
+              <a:t>   - Profitability Classifier: Predict whether a farm will be profitable or loss-making based on input investments.</a:t>
+            </a:r>
+          </a:p>
+          <a:p>
+            <a:pPr>
+              <a:defRPr sz="900" b="0">
+                <a:solidFill>
+                  <a:srgbClr val="1E1E1E"/>
+                </a:solidFill>
+                <a:latin typeface="Arial"/>
+              </a:defRPr>
+            </a:pPr>
+          </a:p>
+          <a:p>
+            <a:pPr>
+              <a:defRPr sz="900" b="0">
+                <a:solidFill>
+                  <a:srgbClr val="1E1E1E"/>
+                </a:solidFill>
+                <a:latin typeface="Arial"/>
+              </a:defRPr>
+            </a:pPr>
+            <a:r>
+              <a:t>2. Interactive Business Intelligence (BI) Dashboards</a:t>
+            </a:r>
+          </a:p>
+          <a:p>
+            <a:pPr>
+              <a:defRPr sz="900" b="0">
+                <a:solidFill>
+                  <a:srgbClr val="1E1E1E"/>
+                </a:solidFill>
+                <a:latin typeface="Arial"/>
+              </a:defRPr>
+            </a:pPr>
+            <a:r>
+              <a:t>   - Streamlit / Dash Web App: Build a web application for farmers/extension officers to filter by State, District, Crop, Season.</a:t>
+            </a:r>
+          </a:p>
+          <a:p>
+            <a:pPr>
+              <a:defRPr sz="900" b="0">
+                <a:solidFill>
+                  <a:srgbClr val="1E1E1E"/>
+                </a:solidFill>
+                <a:latin typeface="Arial"/>
+              </a:defRPr>
+            </a:pPr>
+            <a:r>
+              <a:t>   - PowerBI / Tableau Integration: Create executive dashboards displaying real-time KPIs.</a:t>
+            </a:r>
+          </a:p>
+          <a:p>
+            <a:pPr>
+              <a:defRPr sz="900" b="0">
+                <a:solidFill>
+                  <a:srgbClr val="1E1E1E"/>
+                </a:solidFill>
+                <a:latin typeface="Arial"/>
+              </a:defRPr>
+            </a:pPr>
+          </a:p>
+          <a:p>
+            <a:pPr>
+              <a:defRPr sz="900" b="0">
+                <a:solidFill>
+                  <a:srgbClr val="1E1E1E"/>
+                </a:solidFill>
+                <a:latin typeface="Arial"/>
+              </a:defRPr>
+            </a:pPr>
+            <a:r>
+              <a:t>3. Real-Time IoT &amp; Weather API Integration</a:t>
+            </a:r>
+          </a:p>
+          <a:p>
+            <a:pPr>
+              <a:defRPr sz="900" b="0">
+                <a:solidFill>
+                  <a:srgbClr val="1E1E1E"/>
+                </a:solidFill>
+                <a:latin typeface="Arial"/>
+              </a:defRPr>
+            </a:pPr>
+            <a:r>
+              <a:t>   - Live Climate Data: Integrate Indian Meteorological Department (IMD) APIs for live weather/temperature forecasts.</a:t>
+            </a:r>
+          </a:p>
+          <a:p>
+            <a:pPr>
+              <a:defRPr sz="900" b="0">
+                <a:solidFill>
+                  <a:srgbClr val="1E1E1E"/>
+                </a:solidFill>
+                <a:latin typeface="Arial"/>
+              </a:defRPr>
+            </a:pPr>
+            <a:r>
+              <a:t>   - IoT Soil Sensors: Connect real-time soil moisture and pH sensors to update irrigation schedules.</a:t>
+            </a:r>
+          </a:p>
+          <a:p>
+            <a:pPr>
+              <a:defRPr sz="900" b="0">
+                <a:solidFill>
+                  <a:srgbClr val="1E1E1E"/>
+                </a:solidFill>
+                <a:latin typeface="Arial"/>
+              </a:defRPr>
+            </a:pPr>
+          </a:p>
+          <a:p>
+            <a:pPr>
+              <a:defRPr sz="900" b="0">
+                <a:solidFill>
+                  <a:srgbClr val="1E1E1E"/>
+                </a:solidFill>
+                <a:latin typeface="Arial"/>
+              </a:defRPr>
+            </a:pPr>
+            <a:r>
+              <a:t>4. Geospatial (GIS) &amp; Satellite Imagery Analysis</a:t>
+            </a:r>
+          </a:p>
+          <a:p>
+            <a:pPr>
+              <a:defRPr sz="900" b="0">
+                <a:solidFill>
+                  <a:srgbClr val="1E1E1E"/>
+                </a:solidFill>
+                <a:latin typeface="Arial"/>
+              </a:defRPr>
+            </a:pPr>
+            <a:r>
+              <a:t>   - NDVI Index Tracking: Incorporate satellite imagery (Sentinel-2, Landsat) to track vegetation index and crop health.</a:t>
+            </a:r>
           </a:p>
         </p:txBody>
       </p:sp>
@@ -12486,7 +12716,7 @@
           </a:prstGeom>
         </p:spPr>
         <p:txBody>
-          <a:bodyPr vert="horz" lIns="91440" tIns="45720" rIns="91440" bIns="45720" rtlCol="0">
+          <a:bodyPr vert="horz" lIns="91440" tIns="45720" rIns="91440" bIns="45720" rtlCol="0" wrap="square">
             <a:normAutofit/>
           </a:bodyPr>
           <a:lstStyle>
@@ -12714,7 +12944,214 @@
             </a:lvl9pPr>
           </a:lstStyle>
           <a:p>
+            <a:pPr>
+              <a:defRPr sz="900" b="0">
+                <a:solidFill>
+                  <a:srgbClr val="1E1E1E"/>
+                </a:solidFill>
+                <a:latin typeface="Arial"/>
+              </a:defRPr>
+            </a:pPr>
+            <a:r>
+              <a:t>While the current project focuses strictly on Data Analytics, Statistical Exploration, and Visual Insights, it provides a solid foundation for several advanced future enhancements:</a:t>
+            </a:r>
             <a:endParaRPr lang="en-GB" sz="2000" dirty="0"/>
+          </a:p>
+          <a:p>
+            <a:pPr>
+              <a:defRPr sz="900" b="0">
+                <a:solidFill>
+                  <a:srgbClr val="1E1E1E"/>
+                </a:solidFill>
+                <a:latin typeface="Arial"/>
+              </a:defRPr>
+            </a:pPr>
+          </a:p>
+          <a:p>
+            <a:pPr>
+              <a:defRPr sz="900" b="0">
+                <a:solidFill>
+                  <a:srgbClr val="1E1E1E"/>
+                </a:solidFill>
+                <a:latin typeface="Arial"/>
+              </a:defRPr>
+            </a:pPr>
+            <a:r>
+              <a:t>1. Predictive Machine Learning (ML) Models</a:t>
+            </a:r>
+          </a:p>
+          <a:p>
+            <a:pPr>
+              <a:defRPr sz="900" b="0">
+                <a:solidFill>
+                  <a:srgbClr val="1E1E1E"/>
+                </a:solidFill>
+                <a:latin typeface="Arial"/>
+              </a:defRPr>
+            </a:pPr>
+            <a:r>
+              <a:t>   - Crop Yield Prediction: Implement regression models (Random Forest, XGBoost) to predict yield (Tonnes/Ha).</a:t>
+            </a:r>
+          </a:p>
+          <a:p>
+            <a:pPr>
+              <a:defRPr sz="900" b="0">
+                <a:solidFill>
+                  <a:srgbClr val="1E1E1E"/>
+                </a:solidFill>
+                <a:latin typeface="Arial"/>
+              </a:defRPr>
+            </a:pPr>
+            <a:r>
+              <a:t>   - Pest &amp; Disease Risk Forecasting: Build classification models to forecast high pest risk probability (&gt;50%).</a:t>
+            </a:r>
+          </a:p>
+          <a:p>
+            <a:pPr>
+              <a:defRPr sz="900" b="0">
+                <a:solidFill>
+                  <a:srgbClr val="1E1E1E"/>
+                </a:solidFill>
+                <a:latin typeface="Arial"/>
+              </a:defRPr>
+            </a:pPr>
+            <a:r>
+              <a:t>   - Profitability Classifier: Predict whether a farm will be profitable or loss-making based on input investments.</a:t>
+            </a:r>
+          </a:p>
+          <a:p>
+            <a:pPr>
+              <a:defRPr sz="900" b="0">
+                <a:solidFill>
+                  <a:srgbClr val="1E1E1E"/>
+                </a:solidFill>
+                <a:latin typeface="Arial"/>
+              </a:defRPr>
+            </a:pPr>
+          </a:p>
+          <a:p>
+            <a:pPr>
+              <a:defRPr sz="900" b="0">
+                <a:solidFill>
+                  <a:srgbClr val="1E1E1E"/>
+                </a:solidFill>
+                <a:latin typeface="Arial"/>
+              </a:defRPr>
+            </a:pPr>
+            <a:r>
+              <a:t>2. Interactive Business Intelligence (BI) Dashboards</a:t>
+            </a:r>
+          </a:p>
+          <a:p>
+            <a:pPr>
+              <a:defRPr sz="900" b="0">
+                <a:solidFill>
+                  <a:srgbClr val="1E1E1E"/>
+                </a:solidFill>
+                <a:latin typeface="Arial"/>
+              </a:defRPr>
+            </a:pPr>
+            <a:r>
+              <a:t>   - Streamlit / Dash Web App: Build a web application for farmers/extension officers to filter by State, District, Crop, Season.</a:t>
+            </a:r>
+          </a:p>
+          <a:p>
+            <a:pPr>
+              <a:defRPr sz="900" b="0">
+                <a:solidFill>
+                  <a:srgbClr val="1E1E1E"/>
+                </a:solidFill>
+                <a:latin typeface="Arial"/>
+              </a:defRPr>
+            </a:pPr>
+            <a:r>
+              <a:t>   - PowerBI / Tableau Integration: Create executive dashboards displaying real-time KPIs.</a:t>
+            </a:r>
+          </a:p>
+          <a:p>
+            <a:pPr>
+              <a:defRPr sz="900" b="0">
+                <a:solidFill>
+                  <a:srgbClr val="1E1E1E"/>
+                </a:solidFill>
+                <a:latin typeface="Arial"/>
+              </a:defRPr>
+            </a:pPr>
+          </a:p>
+          <a:p>
+            <a:pPr>
+              <a:defRPr sz="900" b="0">
+                <a:solidFill>
+                  <a:srgbClr val="1E1E1E"/>
+                </a:solidFill>
+                <a:latin typeface="Arial"/>
+              </a:defRPr>
+            </a:pPr>
+            <a:r>
+              <a:t>3. Real-Time IoT &amp; Weather API Integration</a:t>
+            </a:r>
+          </a:p>
+          <a:p>
+            <a:pPr>
+              <a:defRPr sz="900" b="0">
+                <a:solidFill>
+                  <a:srgbClr val="1E1E1E"/>
+                </a:solidFill>
+                <a:latin typeface="Arial"/>
+              </a:defRPr>
+            </a:pPr>
+            <a:r>
+              <a:t>   - Live Climate Data: Integrate Indian Meteorological Department (IMD) APIs for live weather/temperature forecasts.</a:t>
+            </a:r>
+          </a:p>
+          <a:p>
+            <a:pPr>
+              <a:defRPr sz="900" b="0">
+                <a:solidFill>
+                  <a:srgbClr val="1E1E1E"/>
+                </a:solidFill>
+                <a:latin typeface="Arial"/>
+              </a:defRPr>
+            </a:pPr>
+            <a:r>
+              <a:t>   - IoT Soil Sensors: Connect real-time soil moisture and pH sensors to update irrigation schedules.</a:t>
+            </a:r>
+          </a:p>
+          <a:p>
+            <a:pPr>
+              <a:defRPr sz="900" b="0">
+                <a:solidFill>
+                  <a:srgbClr val="1E1E1E"/>
+                </a:solidFill>
+                <a:latin typeface="Arial"/>
+              </a:defRPr>
+            </a:pPr>
+          </a:p>
+          <a:p>
+            <a:pPr>
+              <a:defRPr sz="900" b="0">
+                <a:solidFill>
+                  <a:srgbClr val="1E1E1E"/>
+                </a:solidFill>
+                <a:latin typeface="Arial"/>
+              </a:defRPr>
+            </a:pPr>
+            <a:r>
+              <a:t>4. Geospatial (GIS) &amp; Satellite Imagery Analysis</a:t>
+            </a:r>
+          </a:p>
+          <a:p>
+            <a:pPr>
+              <a:defRPr sz="900" b="0">
+                <a:solidFill>
+                  <a:srgbClr val="1E1E1E"/>
+                </a:solidFill>
+                <a:latin typeface="Arial"/>
+              </a:defRPr>
+            </a:pPr>
+            <a:r>
+              <a:t>   - NDVI Index Tracking: Incorporate satellite imagery (Sentinel-2, Landsat) to track vegetation index and crop health.</a:t>
+            </a:r>
           </a:p>
         </p:txBody>
       </p:sp>
@@ -13148,13 +13585,20 @@
           </a:xfrm>
         </p:spPr>
         <p:txBody>
-          <a:bodyPr>
+          <a:bodyPr wrap="square">
             <a:normAutofit/>
           </a:bodyPr>
           <a:lstStyle/>
           <a:p>
+            <a:pPr>
+              <a:defRPr sz="2400" b="1">
+                <a:solidFill>
+                  <a:srgbClr val="003366"/>
+                </a:solidFill>
+                <a:latin typeface="Arial"/>
+              </a:defRPr>
+            </a:pPr>
             <a:r>
-              <a:rPr lang="en-IN" sz="4000" dirty="0"/>
               <a:t>GitHub Link</a:t>
             </a:r>
           </a:p>
@@ -13184,7 +13628,7 @@
           </a:prstGeom>
         </p:spPr>
         <p:txBody>
-          <a:bodyPr vert="horz" lIns="91440" tIns="45720" rIns="91440" bIns="45720" rtlCol="0">
+          <a:bodyPr vert="horz" lIns="91440" tIns="45720" rIns="91440" bIns="45720" rtlCol="0" wrap="square">
             <a:normAutofit/>
           </a:bodyPr>
           <a:lstStyle>
@@ -13412,6 +13856,17 @@
             </a:lvl9pPr>
           </a:lstStyle>
           <a:p>
+            <a:pPr>
+              <a:defRPr sz="1800" b="1">
+                <a:solidFill>
+                  <a:srgbClr val="0066CC"/>
+                </a:solidFill>
+                <a:latin typeface="Arial"/>
+              </a:defRPr>
+            </a:pPr>
+            <a:r>
+              <a:t>👉 https://github.com/Aryan8182/Vois-data-analyticas-project</a:t>
+            </a:r>
             <a:endParaRPr lang="en-GB" sz="2000" dirty="0"/>
           </a:p>
         </p:txBody>
@@ -13440,7 +13895,7 @@
           </a:prstGeom>
         </p:spPr>
         <p:txBody>
-          <a:bodyPr vert="horz" lIns="91440" tIns="45720" rIns="91440" bIns="45720" rtlCol="0">
+          <a:bodyPr vert="horz" lIns="91440" tIns="45720" rIns="91440" bIns="45720" rtlCol="0" wrap="square">
             <a:normAutofit/>
           </a:bodyPr>
           <a:lstStyle>
@@ -13668,6 +14123,17 @@
             </a:lvl9pPr>
           </a:lstStyle>
           <a:p>
+            <a:pPr>
+              <a:defRPr sz="1800" b="1">
+                <a:solidFill>
+                  <a:srgbClr val="0066CC"/>
+                </a:solidFill>
+                <a:latin typeface="Arial"/>
+              </a:defRPr>
+            </a:pPr>
+            <a:r>
+              <a:t>👉 https://github.com/Aryan8182/Vois-data-analyticas-project</a:t>
+            </a:r>
             <a:endParaRPr lang="en-GB" sz="2000" dirty="0"/>
           </a:p>
         </p:txBody>
@@ -14102,21 +14568,21 @@
           </a:xfrm>
         </p:spPr>
         <p:txBody>
-          <a:bodyPr>
+          <a:bodyPr wrap="square">
             <a:normAutofit fontScale="90000"/>
           </a:bodyPr>
           <a:lstStyle/>
           <a:p>
+            <a:pPr>
+              <a:defRPr sz="1800" b="1">
+                <a:solidFill>
+                  <a:srgbClr val="003366"/>
+                </a:solidFill>
+                <a:latin typeface="Arial"/>
+              </a:defRPr>
+            </a:pPr>
             <a:r>
-              <a:rPr lang="en-IN" sz="3200" dirty="0"/>
-              <a:t>VOIS Course completion certificate - </a:t>
-            </a:r>
-            <a:br>
-              <a:rPr lang="en-IN" sz="3200" dirty="0"/>
-            </a:br>
-            <a:r>
-              <a:rPr lang="en-IN" sz="3200" dirty="0"/>
-              <a:t>Course name- Data Visualization </a:t>
+              <a:t>VOIS Course completion certificate - Course name- Data Visualization</a:t>
             </a:r>
           </a:p>
         </p:txBody>
@@ -14145,7 +14611,7 @@
           </a:prstGeom>
         </p:spPr>
         <p:txBody>
-          <a:bodyPr vert="horz" lIns="91440" tIns="45720" rIns="91440" bIns="45720" rtlCol="0">
+          <a:bodyPr vert="horz" lIns="91440" tIns="45720" rIns="91440" bIns="45720" rtlCol="0" wrap="square">
             <a:normAutofit/>
           </a:bodyPr>
           <a:lstStyle>
@@ -14401,7 +14867,7 @@
           </a:prstGeom>
         </p:spPr>
         <p:txBody>
-          <a:bodyPr vert="horz" lIns="91440" tIns="45720" rIns="91440" bIns="45720" rtlCol="0">
+          <a:bodyPr vert="horz" lIns="91440" tIns="45720" rIns="91440" bIns="45720" rtlCol="0" wrap="square">
             <a:normAutofit/>
           </a:bodyPr>
           <a:lstStyle>
@@ -14633,6 +15099,30 @@
           </a:p>
         </p:txBody>
       </p:sp>
+      <p:pic>
+        <p:nvPicPr>
+          <p:cNvPr id="24" name="Picture 23" descr="certificate.png"/>
+          <p:cNvPicPr>
+            <a:picLocks noChangeAspect="1"/>
+          </p:cNvPicPr>
+          <p:nvPr/>
+        </p:nvPicPr>
+        <p:blipFill>
+          <a:blip r:embed="rId3"/>
+          <a:stretch>
+            <a:fillRect/>
+          </a:stretch>
+        </p:blipFill>
+        <p:spPr>
+          <a:xfrm>
+            <a:off x="1645920" y="1463040"/>
+            <a:ext cx="5852160" cy="4138885"/>
+          </a:xfrm>
+          <a:prstGeom prst="rect">
+            <a:avLst/>
+          </a:prstGeom>
+        </p:spPr>
+      </p:pic>
     </p:spTree>
     <p:extLst>
       <p:ext uri="{BB962C8B-B14F-4D97-AF65-F5344CB8AC3E}">
@@ -17102,7 +17592,7 @@
           </a:xfrm>
         </p:spPr>
         <p:txBody>
-          <a:bodyPr vert="horz" lIns="91440" tIns="45720" rIns="91440" bIns="45720" rtlCol="0" anchor="t">
+          <a:bodyPr vert="horz" lIns="91440" tIns="45720" rIns="91440" bIns="45720" rtlCol="0" anchor="t" wrap="square">
             <a:normAutofit/>
           </a:bodyPr>
           <a:lstStyle/>
@@ -17111,10 +17601,61 @@
               <a:lnSpc>
                 <a:spcPct val="150000"/>
               </a:lnSpc>
+              <a:defRPr sz="1300" b="0">
+                <a:solidFill>
+                  <a:srgbClr val="282828"/>
+                </a:solidFill>
+                <a:latin typeface="Arial"/>
+              </a:defRPr>
             </a:pPr>
             <a:r>
-              <a:rPr lang="en-IN" sz="2800" dirty="0"/>
-              <a:t>(</a:t>
+              <a:t>• Agricultural activities are influenced by seasonal variations in environmental conditions, farming practices, resource availability and market conditions. As a result, agricultural performance may differ from one season to another.</a:t>
+            </a:r>
+          </a:p>
+          <a:p>
+            <a:pPr>
+              <a:defRPr sz="1300" b="0">
+                <a:solidFill>
+                  <a:srgbClr val="282828"/>
+                </a:solidFill>
+                <a:latin typeface="Arial"/>
+              </a:defRPr>
+            </a:pPr>
+          </a:p>
+          <a:p>
+            <a:pPr>
+              <a:defRPr sz="1300" b="0">
+                <a:solidFill>
+                  <a:srgbClr val="282828"/>
+                </a:solidFill>
+                <a:latin typeface="Arial"/>
+              </a:defRPr>
+            </a:pPr>
+            <a:r>
+              <a:t>• However, agricultural data does not clearly explain how agricultural performance changes across seasons or what patterns can be observed in different seasonal conditions.</a:t>
+            </a:r>
+          </a:p>
+          <a:p>
+            <a:pPr>
+              <a:defRPr sz="1300" b="0">
+                <a:solidFill>
+                  <a:srgbClr val="282828"/>
+                </a:solidFill>
+                <a:latin typeface="Arial"/>
+              </a:defRPr>
+            </a:pPr>
+          </a:p>
+          <a:p>
+            <a:pPr>
+              <a:defRPr sz="1300" b="0">
+                <a:solidFill>
+                  <a:srgbClr val="282828"/>
+                </a:solidFill>
+                <a:latin typeface="Arial"/>
+              </a:defRPr>
+            </a:pPr>
+            <a:r>
+              <a:t>• The problem is to analyze the given agricultural dataset and investigate seasonal differences in agricultural performance by identifying meaningful patterns, trends, relationships and variations within the available data.</a:t>
             </a:r>
           </a:p>
         </p:txBody>
@@ -17142,14 +17683,21 @@
           </a:xfrm>
         </p:spPr>
         <p:txBody>
-          <a:bodyPr>
+          <a:bodyPr wrap="square">
             <a:normAutofit fontScale="90000"/>
           </a:bodyPr>
           <a:lstStyle/>
           <a:p>
+            <a:pPr>
+              <a:defRPr sz="2400" b="1">
+                <a:solidFill>
+                  <a:srgbClr val="003366"/>
+                </a:solidFill>
+                <a:latin typeface="Arial"/>
+              </a:defRPr>
+            </a:pPr>
             <a:r>
-              <a:rPr lang="en-US" dirty="0"/>
-              <a:t>PROBLEM  STATEMENT</a:t>
+              <a:t>PROBLEM STATEMENT</a:t>
             </a:r>
             <a:endParaRPr lang="en-IN" dirty="0"/>
           </a:p>
@@ -17525,26 +18073,95 @@
           </a:xfrm>
         </p:spPr>
         <p:txBody>
-          <a:bodyPr>
+          <a:bodyPr wrap="square">
             <a:normAutofit fontScale="90000"/>
           </a:bodyPr>
           <a:lstStyle/>
           <a:p>
+            <a:pPr>
+              <a:defRPr sz="1100" b="0">
+                <a:solidFill>
+                  <a:srgbClr val="1E1E1E"/>
+                </a:solidFill>
+                <a:latin typeface="Arial"/>
+              </a:defRPr>
+            </a:pPr>
             <a:r>
-              <a:rPr lang="en-GB" dirty="0"/>
-              <a:t>Project Description</a:t>
+              <a:t>The Seasonal Agriculture Performance Analysis project is a focused Data Analytics major project designed to investigate how agricultural performance, resource usage efficiency, and farm profitability vary across different farming seasons (Kharif, Rabi, and Zaid) in India.</a:t>
             </a:r>
-            <a:br>
-              <a:rPr lang="en-GB" dirty="0"/>
-            </a:br>
+            <a:endParaRPr lang="en-IN" dirty="0"/>
+          </a:p>
+          <a:p>
+            <a:pPr>
+              <a:defRPr sz="1100" b="0">
+                <a:solidFill>
+                  <a:srgbClr val="1E1E1E"/>
+                </a:solidFill>
+                <a:latin typeface="Arial"/>
+              </a:defRPr>
+            </a:pPr>
+          </a:p>
+          <a:p>
+            <a:pPr>
+              <a:defRPr sz="1100" b="0">
+                <a:solidFill>
+                  <a:srgbClr val="1E1E1E"/>
+                </a:solidFill>
+                <a:latin typeface="Arial"/>
+              </a:defRPr>
+            </a:pPr>
             <a:r>
-              <a:rPr lang="en-GB" dirty="0"/>
-              <a:t>[write detail description about your project ] </a:t>
+              <a:t>Using a comprehensive dataset of 4,000 farm-level records across 28 numerical and categorical parameters, the project applies data cleaning, statistical modeling, univariate, bivariate, and multivariate visualizations to discover meaningful seasonal patterns, environmental relationships, resource trade-offs, and economic outcomes.</a:t>
             </a:r>
-            <a:br>
-              <a:rPr lang="en-GB" dirty="0"/>
-            </a:br>
-            <a:endParaRPr lang="en-IN" dirty="0"/>
+          </a:p>
+          <a:p>
+            <a:pPr>
+              <a:defRPr sz="1100" b="0">
+                <a:solidFill>
+                  <a:srgbClr val="1E1E1E"/>
+                </a:solidFill>
+                <a:latin typeface="Arial"/>
+              </a:defRPr>
+            </a:pPr>
+          </a:p>
+          <a:p>
+            <a:pPr>
+              <a:defRPr sz="1100" b="0">
+                <a:solidFill>
+                  <a:srgbClr val="1E1E1E"/>
+                </a:solidFill>
+                <a:latin typeface="Arial"/>
+              </a:defRPr>
+            </a:pPr>
+            <a:r>
+              <a:t>Program: VOIS AICTE Batch1 (2026-2027)</a:t>
+            </a:r>
+          </a:p>
+          <a:p>
+            <a:pPr>
+              <a:defRPr sz="1100" b="0">
+                <a:solidFill>
+                  <a:srgbClr val="1E1E1E"/>
+                </a:solidFill>
+                <a:latin typeface="Arial"/>
+              </a:defRPr>
+            </a:pPr>
+            <a:r>
+              <a:t>Domain: Agriculture &amp; Data Analytics</a:t>
+            </a:r>
+          </a:p>
+          <a:p>
+            <a:pPr>
+              <a:defRPr sz="1100" b="0">
+                <a:solidFill>
+                  <a:srgbClr val="1E1E1E"/>
+                </a:solidFill>
+                <a:latin typeface="Arial"/>
+              </a:defRPr>
+            </a:pPr>
+            <a:r>
+              <a:t>Tools Used: Python, Pandas, NumPy, Matplotlib, Seaborn, Jupyter Notebook</a:t>
+            </a:r>
           </a:p>
         </p:txBody>
       </p:sp>
@@ -17792,7 +18409,7 @@
           </a:xfrm>
         </p:spPr>
         <p:txBody>
-          <a:bodyPr>
+          <a:bodyPr wrap="square">
             <a:normAutofit/>
           </a:bodyPr>
           <a:lstStyle/>
@@ -17801,8 +18418,213 @@
               <a:lnSpc>
                 <a:spcPct val="150000"/>
               </a:lnSpc>
+              <a:defRPr sz="1000" b="0">
+                <a:solidFill>
+                  <a:srgbClr val="1E1E1E"/>
+                </a:solidFill>
+                <a:latin typeface="Arial"/>
+              </a:defRPr>
             </a:pPr>
+            <a:r>
+              <a:t>1. Farmers &amp; Agricultural Producers</a:t>
+            </a:r>
             <a:endParaRPr lang="en-IN" sz="3600" dirty="0"/>
+          </a:p>
+          <a:p>
+            <a:pPr>
+              <a:defRPr sz="1000" b="0">
+                <a:solidFill>
+                  <a:srgbClr val="1E1E1E"/>
+                </a:solidFill>
+                <a:latin typeface="Arial"/>
+              </a:defRPr>
+            </a:pPr>
+            <a:r>
+              <a:t>   - Decide which crop to plant in which season (Kharif, Rabi, Zaid) to maximize profit.</a:t>
+            </a:r>
+          </a:p>
+          <a:p>
+            <a:pPr>
+              <a:defRPr sz="1000" b="0">
+                <a:solidFill>
+                  <a:srgbClr val="1E1E1E"/>
+                </a:solidFill>
+                <a:latin typeface="Arial"/>
+              </a:defRPr>
+            </a:pPr>
+            <a:r>
+              <a:t>   - Choose the most water-efficient irrigation method (e.g. Flood to Drip/Sprinkler).</a:t>
+            </a:r>
+          </a:p>
+          <a:p>
+            <a:pPr>
+              <a:defRPr sz="1000" b="0">
+                <a:solidFill>
+                  <a:srgbClr val="1E1E1E"/>
+                </a:solidFill>
+                <a:latin typeface="Arial"/>
+              </a:defRPr>
+            </a:pPr>
+            <a:r>
+              <a:t>   - Time pesticide/fertilizer applications to prevent high-humidity Kharif pest losses.</a:t>
+            </a:r>
+          </a:p>
+          <a:p>
+            <a:pPr>
+              <a:defRPr sz="1000" b="0">
+                <a:solidFill>
+                  <a:srgbClr val="1E1E1E"/>
+                </a:solidFill>
+                <a:latin typeface="Arial"/>
+              </a:defRPr>
+            </a:pPr>
+          </a:p>
+          <a:p>
+            <a:pPr>
+              <a:defRPr sz="1000" b="0">
+                <a:solidFill>
+                  <a:srgbClr val="1E1E1E"/>
+                </a:solidFill>
+                <a:latin typeface="Arial"/>
+              </a:defRPr>
+            </a:pPr>
+            <a:r>
+              <a:t>2. Agricultural Planners &amp; Government Policymakers (e.g. Ministry of Ag, ICAR, NABARD)</a:t>
+            </a:r>
+          </a:p>
+          <a:p>
+            <a:pPr>
+              <a:defRPr sz="1000" b="0">
+                <a:solidFill>
+                  <a:srgbClr val="1E1E1E"/>
+                </a:solidFill>
+                <a:latin typeface="Arial"/>
+              </a:defRPr>
+            </a:pPr>
+            <a:r>
+              <a:t>   - Support evidence-based seasonal planning and regional agricultural policies.</a:t>
+            </a:r>
+          </a:p>
+          <a:p>
+            <a:pPr>
+              <a:defRPr sz="1000" b="0">
+                <a:solidFill>
+                  <a:srgbClr val="1E1E1E"/>
+                </a:solidFill>
+                <a:latin typeface="Arial"/>
+              </a:defRPr>
+            </a:pPr>
+            <a:r>
+              <a:t>   - Allocate water resources, subsidies, and micro-irrigation grants effectively.</a:t>
+            </a:r>
+          </a:p>
+          <a:p>
+            <a:pPr>
+              <a:defRPr sz="1000" b="0">
+                <a:solidFill>
+                  <a:srgbClr val="1E1E1E"/>
+                </a:solidFill>
+                <a:latin typeface="Arial"/>
+              </a:defRPr>
+            </a:pPr>
+          </a:p>
+          <a:p>
+            <a:pPr>
+              <a:defRPr sz="1000" b="0">
+                <a:solidFill>
+                  <a:srgbClr val="1E1E1E"/>
+                </a:solidFill>
+                <a:latin typeface="Arial"/>
+              </a:defRPr>
+            </a:pPr>
+            <a:r>
+              <a:t>3. Agri-Tech &amp; Farm Input Supply Companies (Fertilizers, Pesticides, Seeds)</a:t>
+            </a:r>
+          </a:p>
+          <a:p>
+            <a:pPr>
+              <a:defRPr sz="1000" b="0">
+                <a:solidFill>
+                  <a:srgbClr val="1E1E1E"/>
+                </a:solidFill>
+                <a:latin typeface="Arial"/>
+              </a:defRPr>
+            </a:pPr>
+            <a:r>
+              <a:t>   - Forecast seasonal demand for NPK fertilizers, high-quality seeds, and pesticides.</a:t>
+            </a:r>
+          </a:p>
+          <a:p>
+            <a:pPr>
+              <a:defRPr sz="1000" b="0">
+                <a:solidFill>
+                  <a:srgbClr val="1E1E1E"/>
+                </a:solidFill>
+                <a:latin typeface="Arial"/>
+              </a:defRPr>
+            </a:pPr>
+          </a:p>
+          <a:p>
+            <a:pPr>
+              <a:defRPr sz="1000" b="0">
+                <a:solidFill>
+                  <a:srgbClr val="1E1E1E"/>
+                </a:solidFill>
+                <a:latin typeface="Arial"/>
+              </a:defRPr>
+            </a:pPr>
+            <a:r>
+              <a:t>4. Agricultural Extension Officers &amp; Agronomists</a:t>
+            </a:r>
+          </a:p>
+          <a:p>
+            <a:pPr>
+              <a:defRPr sz="1000" b="0">
+                <a:solidFill>
+                  <a:srgbClr val="1E1E1E"/>
+                </a:solidFill>
+                <a:latin typeface="Arial"/>
+              </a:defRPr>
+            </a:pPr>
+            <a:r>
+              <a:t>   - Provide empirical, data-backed advisory services to local farming communities.</a:t>
+            </a:r>
+          </a:p>
+          <a:p>
+            <a:pPr>
+              <a:defRPr sz="1000" b="0">
+                <a:solidFill>
+                  <a:srgbClr val="1E1E1E"/>
+                </a:solidFill>
+                <a:latin typeface="Arial"/>
+              </a:defRPr>
+            </a:pPr>
+          </a:p>
+          <a:p>
+            <a:pPr>
+              <a:defRPr sz="1000" b="0">
+                <a:solidFill>
+                  <a:srgbClr val="1E1E1E"/>
+                </a:solidFill>
+                <a:latin typeface="Arial"/>
+              </a:defRPr>
+            </a:pPr>
+            <a:r>
+              <a:t>5. Crop Insurance Companies &amp; Agricultural Banks</a:t>
+            </a:r>
+          </a:p>
+          <a:p>
+            <a:pPr>
+              <a:defRPr sz="1000" b="0">
+                <a:solidFill>
+                  <a:srgbClr val="1E1E1E"/>
+                </a:solidFill>
+                <a:latin typeface="Arial"/>
+              </a:defRPr>
+            </a:pPr>
+            <a:r>
+              <a:t>   - Assess financial risk profiles and design seasonal credit/insurance schemes.</a:t>
+            </a:r>
           </a:p>
         </p:txBody>
       </p:sp>
@@ -17829,13 +18651,20 @@
           </a:xfrm>
         </p:spPr>
         <p:txBody>
-          <a:bodyPr>
+          <a:bodyPr wrap="square">
             <a:normAutofit/>
           </a:bodyPr>
           <a:lstStyle/>
           <a:p>
+            <a:pPr>
+              <a:defRPr sz="2200" b="1">
+                <a:solidFill>
+                  <a:srgbClr val="003366"/>
+                </a:solidFill>
+                <a:latin typeface="Arial"/>
+              </a:defRPr>
+            </a:pPr>
             <a:r>
-              <a:rPr lang="en-US" sz="3200" dirty="0"/>
               <a:t>WHO ARE THE END USERS?</a:t>
             </a:r>
             <a:endParaRPr lang="en-IN" sz="2000" dirty="0"/>
@@ -18248,15 +19077,233 @@
           </a:xfrm>
         </p:spPr>
         <p:txBody>
-          <a:bodyPr/>
+          <a:bodyPr wrap="square"/>
           <a:lstStyle/>
           <a:p>
             <a:pPr lvl="1">
               <a:lnSpc>
                 <a:spcPct val="150000"/>
               </a:lnSpc>
+              <a:defRPr sz="1000" b="0">
+                <a:solidFill>
+                  <a:srgbClr val="1E1E1E"/>
+                </a:solidFill>
+                <a:latin typeface="Arial"/>
+              </a:defRPr>
             </a:pPr>
+            <a:r>
+              <a:t>1. Core Programming Language</a:t>
+            </a:r>
             <a:endParaRPr lang="en-IN" dirty="0"/>
+          </a:p>
+          <a:p>
+            <a:pPr>
+              <a:defRPr sz="1000" b="0">
+                <a:solidFill>
+                  <a:srgbClr val="1E1E1E"/>
+                </a:solidFill>
+                <a:latin typeface="Arial"/>
+              </a:defRPr>
+            </a:pPr>
+            <a:r>
+              <a:t>   Python: Primary language for data manipulation, statistics, and reporting.</a:t>
+            </a:r>
+          </a:p>
+          <a:p>
+            <a:pPr>
+              <a:defRPr sz="1000" b="0">
+                <a:solidFill>
+                  <a:srgbClr val="1E1E1E"/>
+                </a:solidFill>
+                <a:latin typeface="Arial"/>
+              </a:defRPr>
+            </a:pPr>
+          </a:p>
+          <a:p>
+            <a:pPr>
+              <a:defRPr sz="1000" b="0">
+                <a:solidFill>
+                  <a:srgbClr val="1E1E1E"/>
+                </a:solidFill>
+                <a:latin typeface="Arial"/>
+              </a:defRPr>
+            </a:pPr>
+            <a:r>
+              <a:t>2. Data Analysis &amp; Processing Libraries</a:t>
+            </a:r>
+          </a:p>
+          <a:p>
+            <a:pPr>
+              <a:defRPr sz="1000" b="0">
+                <a:solidFill>
+                  <a:srgbClr val="1E1E1E"/>
+                </a:solidFill>
+                <a:latin typeface="Arial"/>
+              </a:defRPr>
+            </a:pPr>
+            <a:r>
+              <a:t>   Pandas: Data loading, DataFrame manipulation, missing value imputation, groupby.</a:t>
+            </a:r>
+          </a:p>
+          <a:p>
+            <a:pPr>
+              <a:defRPr sz="1000" b="0">
+                <a:solidFill>
+                  <a:srgbClr val="1E1E1E"/>
+                </a:solidFill>
+                <a:latin typeface="Arial"/>
+              </a:defRPr>
+            </a:pPr>
+            <a:r>
+              <a:t>   NumPy: Vector mathematical operations, array transformations, conditional logic.</a:t>
+            </a:r>
+          </a:p>
+          <a:p>
+            <a:pPr>
+              <a:defRPr sz="1000" b="0">
+                <a:solidFill>
+                  <a:srgbClr val="1E1E1E"/>
+                </a:solidFill>
+                <a:latin typeface="Arial"/>
+              </a:defRPr>
+            </a:pPr>
+          </a:p>
+          <a:p>
+            <a:pPr>
+              <a:defRPr sz="1000" b="0">
+                <a:solidFill>
+                  <a:srgbClr val="1E1E1E"/>
+                </a:solidFill>
+                <a:latin typeface="Arial"/>
+              </a:defRPr>
+            </a:pPr>
+            <a:r>
+              <a:t>3. Data Visualization Libraries</a:t>
+            </a:r>
+          </a:p>
+          <a:p>
+            <a:pPr>
+              <a:defRPr sz="1000" b="0">
+                <a:solidFill>
+                  <a:srgbClr val="1E1E1E"/>
+                </a:solidFill>
+                <a:latin typeface="Arial"/>
+              </a:defRPr>
+            </a:pPr>
+            <a:r>
+              <a:t>   Matplotlib: Custom figure creation, pie charts, subplots, 300 DPI exports.</a:t>
+            </a:r>
+          </a:p>
+          <a:p>
+            <a:pPr>
+              <a:defRPr sz="1000" b="0">
+                <a:solidFill>
+                  <a:srgbClr val="1E1E1E"/>
+                </a:solidFill>
+                <a:latin typeface="Arial"/>
+              </a:defRPr>
+            </a:pPr>
+            <a:r>
+              <a:t>   Seaborn: Statistical plots, KDE distributions, boxplots, correlation heatmaps.</a:t>
+            </a:r>
+          </a:p>
+          <a:p>
+            <a:pPr>
+              <a:defRPr sz="1000" b="0">
+                <a:solidFill>
+                  <a:srgbClr val="1E1E1E"/>
+                </a:solidFill>
+                <a:latin typeface="Arial"/>
+              </a:defRPr>
+            </a:pPr>
+          </a:p>
+          <a:p>
+            <a:pPr>
+              <a:defRPr sz="1000" b="0">
+                <a:solidFill>
+                  <a:srgbClr val="1E1E1E"/>
+                </a:solidFill>
+                <a:latin typeface="Arial"/>
+              </a:defRPr>
+            </a:pPr>
+            <a:r>
+              <a:t>4. Development Environments &amp; Platforms</a:t>
+            </a:r>
+          </a:p>
+          <a:p>
+            <a:pPr>
+              <a:defRPr sz="1000" b="0">
+                <a:solidFill>
+                  <a:srgbClr val="1E1E1E"/>
+                </a:solidFill>
+                <a:latin typeface="Arial"/>
+              </a:defRPr>
+            </a:pPr>
+            <a:r>
+              <a:t>   Jupyter Notebook (.ipynb): Interactive step-by-step markdown documentation and code.</a:t>
+            </a:r>
+          </a:p>
+          <a:p>
+            <a:pPr>
+              <a:defRPr sz="1000" b="0">
+                <a:solidFill>
+                  <a:srgbClr val="1E1E1E"/>
+                </a:solidFill>
+                <a:latin typeface="Arial"/>
+              </a:defRPr>
+            </a:pPr>
+            <a:r>
+              <a:t>   Anaconda Distribution: Scientific computing python distribution.</a:t>
+            </a:r>
+          </a:p>
+          <a:p>
+            <a:pPr>
+              <a:defRPr sz="1000" b="0">
+                <a:solidFill>
+                  <a:srgbClr val="1E1E1E"/>
+                </a:solidFill>
+                <a:latin typeface="Arial"/>
+              </a:defRPr>
+            </a:pPr>
+            <a:r>
+              <a:t>   Python Pipeline Script (seasonal_agriculture_analysis.py): Automated pipeline script.</a:t>
+            </a:r>
+          </a:p>
+          <a:p>
+            <a:pPr>
+              <a:defRPr sz="1000" b="0">
+                <a:solidFill>
+                  <a:srgbClr val="1E1E1E"/>
+                </a:solidFill>
+                <a:latin typeface="Arial"/>
+              </a:defRPr>
+            </a:pPr>
+          </a:p>
+          <a:p>
+            <a:pPr>
+              <a:defRPr sz="1000" b="0">
+                <a:solidFill>
+                  <a:srgbClr val="1E1E1E"/>
+                </a:solidFill>
+                <a:latin typeface="Arial"/>
+              </a:defRPr>
+            </a:pPr>
+            <a:r>
+              <a:t>5. File Formats</a:t>
+            </a:r>
+          </a:p>
+          <a:p>
+            <a:pPr>
+              <a:defRPr sz="1000" b="0">
+                <a:solidFill>
+                  <a:srgbClr val="1E1E1E"/>
+                </a:solidFill>
+                <a:latin typeface="Arial"/>
+              </a:defRPr>
+            </a:pPr>
+            <a:r>
+              <a:t>   CSV: seasonal_agriculture_performance_dataset.csv (4000 farm records x 28 columns).</a:t>
+            </a:r>
           </a:p>
         </p:txBody>
       </p:sp>
@@ -18283,13 +19330,20 @@
           </a:xfrm>
         </p:spPr>
         <p:txBody>
-          <a:bodyPr>
+          <a:bodyPr wrap="square">
             <a:normAutofit/>
           </a:bodyPr>
           <a:lstStyle/>
           <a:p>
+            <a:pPr>
+              <a:defRPr sz="2200" b="1">
+                <a:solidFill>
+                  <a:srgbClr val="003366"/>
+                </a:solidFill>
+                <a:latin typeface="Arial"/>
+              </a:defRPr>
+            </a:pPr>
             <a:r>
-              <a:rPr lang="en-US" dirty="0"/>
               <a:t>Technology Used</a:t>
             </a:r>
           </a:p>
@@ -18630,14 +19684,21 @@
           </a:xfrm>
         </p:spPr>
         <p:txBody>
-          <a:bodyPr>
+          <a:bodyPr wrap="square">
             <a:normAutofit/>
           </a:bodyPr>
           <a:lstStyle/>
           <a:p>
+            <a:pPr>
+              <a:defRPr sz="2400" b="1">
+                <a:solidFill>
+                  <a:srgbClr val="003366"/>
+                </a:solidFill>
+                <a:latin typeface="Arial"/>
+              </a:defRPr>
+            </a:pPr>
             <a:r>
-              <a:rPr lang="en-GB" dirty="0"/>
-              <a:t>RESULTS </a:t>
+              <a:t>Result</a:t>
             </a:r>
             <a:endParaRPr lang="en-IN" dirty="0"/>
           </a:p>
@@ -19178,7 +20239,7 @@
           </a:xfrm>
         </p:spPr>
         <p:txBody>
-          <a:bodyPr vert="horz" lIns="91440" tIns="45720" rIns="91440" bIns="45720" rtlCol="0" anchor="t">
+          <a:bodyPr vert="horz" lIns="91440" tIns="45720" rIns="91440" bIns="45720" rtlCol="0" anchor="t" wrap="square">
             <a:normAutofit/>
           </a:bodyPr>
           <a:lstStyle/>
@@ -19186,10 +20247,6 @@
             <a:pPr marL="0" indent="0">
               <a:buNone/>
             </a:pPr>
-            <a:r>
-              <a:rPr lang="en-US" dirty="0"/>
-              <a:t>[Add screen shots of your code ]</a:t>
-            </a:r>
             <a:endParaRPr lang="en-IN" dirty="0"/>
           </a:p>
         </p:txBody>
@@ -19740,14 +20797,21 @@
           </a:xfrm>
         </p:spPr>
         <p:txBody>
-          <a:bodyPr>
+          <a:bodyPr wrap="square">
             <a:normAutofit/>
           </a:bodyPr>
           <a:lstStyle/>
           <a:p>
+            <a:pPr>
+              <a:defRPr sz="2400" b="1">
+                <a:solidFill>
+                  <a:srgbClr val="003366"/>
+                </a:solidFill>
+                <a:latin typeface="Arial"/>
+              </a:defRPr>
+            </a:pPr>
             <a:r>
-              <a:rPr lang="en-GB" dirty="0"/>
-              <a:t>RESULTS </a:t>
+              <a:t>Result</a:t>
             </a:r>
             <a:endParaRPr lang="en-IN" dirty="0"/>
           </a:p>
@@ -20288,16 +21352,12 @@
           </a:xfrm>
         </p:spPr>
         <p:txBody>
-          <a:bodyPr/>
+          <a:bodyPr wrap="square"/>
           <a:lstStyle/>
           <a:p>
             <a:pPr marL="0" indent="0">
               <a:buNone/>
             </a:pPr>
-            <a:r>
-              <a:rPr lang="en-US" dirty="0"/>
-              <a:t>[Add screen shots of your code ]</a:t>
-            </a:r>
             <a:endParaRPr lang="en-IN" dirty="0"/>
           </a:p>
         </p:txBody>
@@ -20848,14 +21908,21 @@
           </a:xfrm>
         </p:spPr>
         <p:txBody>
-          <a:bodyPr>
+          <a:bodyPr wrap="square">
             <a:normAutofit/>
           </a:bodyPr>
           <a:lstStyle/>
           <a:p>
+            <a:pPr>
+              <a:defRPr sz="2400" b="1">
+                <a:solidFill>
+                  <a:srgbClr val="003366"/>
+                </a:solidFill>
+                <a:latin typeface="Arial"/>
+              </a:defRPr>
+            </a:pPr>
             <a:r>
-              <a:rPr lang="en-GB" dirty="0"/>
-              <a:t>RESULTS </a:t>
+              <a:t>Result</a:t>
             </a:r>
             <a:endParaRPr lang="en-IN" dirty="0"/>
           </a:p>
@@ -21396,16 +22463,12 @@
           </a:xfrm>
         </p:spPr>
         <p:txBody>
-          <a:bodyPr/>
+          <a:bodyPr wrap="square"/>
           <a:lstStyle/>
           <a:p>
             <a:pPr marL="0" indent="0">
               <a:buNone/>
             </a:pPr>
-            <a:r>
-              <a:rPr lang="en-US" dirty="0"/>
-              <a:t>[Add screen shots of your code ]</a:t>
-            </a:r>
             <a:endParaRPr lang="en-IN" dirty="0"/>
           </a:p>
         </p:txBody>
@@ -21956,14 +23019,21 @@
           </a:xfrm>
         </p:spPr>
         <p:txBody>
-          <a:bodyPr>
+          <a:bodyPr wrap="square">
             <a:normAutofit/>
           </a:bodyPr>
           <a:lstStyle/>
           <a:p>
+            <a:pPr>
+              <a:defRPr sz="2400" b="1">
+                <a:solidFill>
+                  <a:srgbClr val="003366"/>
+                </a:solidFill>
+                <a:latin typeface="Arial"/>
+              </a:defRPr>
+            </a:pPr>
             <a:r>
-              <a:rPr lang="en-GB" dirty="0"/>
-              <a:t>RESULTS </a:t>
+              <a:t>Result</a:t>
             </a:r>
             <a:endParaRPr lang="en-IN" dirty="0"/>
           </a:p>
@@ -22504,16 +23574,12 @@
           </a:xfrm>
         </p:spPr>
         <p:txBody>
-          <a:bodyPr/>
+          <a:bodyPr wrap="square"/>
           <a:lstStyle/>
           <a:p>
             <a:pPr marL="0" indent="0">
               <a:buNone/>
             </a:pPr>
-            <a:r>
-              <a:rPr lang="en-US" dirty="0"/>
-              <a:t>[Add screen shots of your code ]</a:t>
-            </a:r>
             <a:endParaRPr lang="en-IN" dirty="0"/>
           </a:p>
         </p:txBody>

</xml_diff>